<commit_message>
docs: refresh executive slides with the latest architecture
Regenerate the PowerPoint, PDF and provenance manifest using the updated ELK-routed architecture already on main.

Co-authored-by: Copilot App <223556219+Copilot@users.noreply.github.com>
Copilot-Session: 29872254-6eaf-431f-92d0-cfe0f0413c07
</commit_message>
<xml_diff>
--- a/outputs/business_review.pptx
+++ b/outputs/business_review.pptx
@@ -659,8 +659,8 @@
 Public dashboard (last deployed commit): https://glejdis.github.io/zenline-category-opportunity-review/
 EVIDENCE, DEFINITIONS AND LIMITS
 Architecture specification SHA-256: 8b0b0cdb55bd7858c22283a64e281a43706bcb4e1abb7d6793cdf256a6d05a54
-Shared architecture image SHA-256: 8db457d15dd9c44a94fbbb9b3693967b7ae3ca9bf91c5bfb69d191845ae95f0c
-Shared renderer and source/output hashes: {"text_hash_normalization":"utf8-lf","source_sha256":"1abf37b2befec5216fe2851d18fa2a8b193269d6ed3f6ab51cd867bee6b9ef25","svg_sha256":"2627e177410c83485d9026633ca531cf8c3fe8ca118e0c563e2b3059b8ef131f","png_sha256":"8db457d15dd9c44a94fbbb9b3693967b7ae3ca9bf91c5bfb69d191845ae95f0c","config_sha256":"8c69d157c7a7397b4b774902c2df4d02c696f3afeeddcae783461fae8ca4de11","renderer":"@mermaid-js/mermaid-cli 11.17.0"}
+Shared architecture image SHA-256: 4a171db01e7d13c18559aa45b7d2fcf991dc3864cc234d60d311482337a65bd2
+Shared renderer and source/output hashes: {"text_hash_normalization":"utf8-lf","source_sha256":"1abf37b2befec5216fe2851d18fa2a8b193269d6ed3f6ab51cd867bee6b9ef25","svg_sha256":"744ebd339149be91eac095ad6455967d6c648f17a95bc15bd4da67d449bde113","png_sha256":"4a171db01e7d13c18559aa45b7d2fcf991dc3864cc234d60d311482337a65bd2","config_sha256":"f132a8d9edf00c7b0f3b09ecd5257ee348b228e98c9cd1e7e22bf73522ec74fd","renderer":"@mermaid-js/mermaid-cli 11.17.0"}
 {
   "title": "A production path for shared, governed category decisions",
   "status": "Proposed architecture - not deployed",
@@ -3503,8 +3503,8 @@
         </p:blipFill>
         <p:spPr>
           <a:xfrm>
-            <a:off x="688307" y="1536192"/>
-            <a:ext cx="10815385" cy="4590288"/>
+            <a:off x="504444" y="1547244"/>
+            <a:ext cx="11183112" cy="4568184"/>
           </a:xfrm>
           <a:prstGeom prst="rect">
             <a:avLst/>

</xml_diff>